<commit_message>
Finalize submission deck: result-oriented titles, Emp ID, refined copy
- Removed jury-facing subtitle lines (e.g. "what the jury will see");
  slide titles are now result-oriented statements (problem framing,
  "22%->94% accuracy · 74% fewer tokens", "trusted deflection that gets
  smarter every night"). Demo card relabeled "DEMO FLOW — LIVE HIGHLIGHTS".
- Emp ID 2437783 filled in.
- Impact card now leads with the numbers; short description sharpened.
- Title slide left unchanged.

Co-Authored-By: Claude Fable 5 <noreply@anthropic.com>
</commit_message>
<xml_diff>
--- a/submission/TCS_AMD_AI_Hackathon_Submission_TruthLine.pptx
+++ b/submission/TCS_AMD_AI_Hackathon_Submission_TruthLine.pptx
@@ -1909,7 +1909,7 @@
                 <a:ea typeface="Calibri" pitchFamily="34" charset="-122"/>
                 <a:cs typeface="Calibri" pitchFamily="34" charset="-120"/>
               </a:rPr>
-              <a:t>Prashant Patil   (Emp ID: &lt;fill your employee ID&gt;)</a:t>
+              <a:t>Prashant Patil   (Emp ID: 2437783)</a:t>
             </a:r>
             <a:endParaRPr lang="en-US" sz="1250" dirty="0"/>
           </a:p>
@@ -2233,7 +2233,7 @@
                 <a:ea typeface="Calibri" pitchFamily="34" charset="-122"/>
                 <a:cs typeface="Calibri" pitchFamily="34" charset="-120"/>
               </a:rPr>
-              <a:t>We fine-tuned Qwen3-14B on AMD Instinct MI300X so proprietary telecom knowledge — internal billing codes, router hardware, error codes — lives in the model's weights, wrapped in an agentic pipeline (guardrails, clarity gate, semantic cache, hybrid RAG, model router, trust gate, MCP enterprise tools, data flywheel). Measured held-out accuracy rose from 22% (base) to 94% (fine-tuned), at 74% fewer tokens per answer.</a:t>
+              <a:t>A domain-expert telecom support LLM. We fine-tuned Qwen3-14B on AMD Instinct MI300X so proprietary knowledge — internal billing codes, router hardware, error codes — lives in the model's weights, wrapped in an agentic pipeline: guardrails, clarity gate, semantic cache, hybrid RAG, model router, trust gate, MCP enterprise tools, and a data flywheel. Result: held-out accuracy 22% → 94%, at 74% fewer tokens per answer — on one AMD GPU, with zero external API calls.</a:t>
             </a:r>
             <a:endParaRPr lang="en-US" sz="1250" dirty="0"/>
           </a:p>
@@ -2391,7 +2391,7 @@
                 <a:ea typeface="Georgia" pitchFamily="34" charset="-122"/>
                 <a:cs typeface="Georgia" pitchFamily="34" charset="-120"/>
               </a:rPr>
-              <a:t>The problem we set out to solve</a:t>
+              <a:t>Generic LLMs hallucinate on proprietary telecom knowledge</a:t>
             </a:r>
             <a:endParaRPr lang="en-US" sz="3000" dirty="0"/>
           </a:p>
@@ -3126,7 +3126,7 @@
                 <a:ea typeface="Georgia" pitchFamily="34" charset="-122"/>
                 <a:cs typeface="Georgia" pitchFamily="34" charset="-120"/>
               </a:rPr>
-              <a:t>Eight-stage agentic pipeline — every query earns its way to the GPU</a:t>
+              <a:t>Eight-stage agentic pipeline, fully on AMD MI300X</a:t>
             </a:r>
             <a:endParaRPr lang="en-US" sz="3000" dirty="0"/>
           </a:p>
@@ -4982,7 +4982,7 @@
                 <a:ea typeface="Georgia" pitchFamily="34" charset="-122"/>
                 <a:cs typeface="Georgia" pitchFamily="34" charset="-120"/>
               </a:rPr>
-              <a:t>Measured results, base vs fine-tuned</a:t>
+              <a:t>22% → 94% accuracy · 74% fewer tokens · ~60s retrain</a:t>
             </a:r>
             <a:endParaRPr lang="en-US" sz="3000" dirty="0"/>
           </a:p>
@@ -6033,7 +6033,7 @@
                 <a:ea typeface="Georgia" pitchFamily="34" charset="-122"/>
                 <a:cs typeface="Georgia" pitchFamily="34" charset="-120"/>
               </a:rPr>
-              <a:t>Why it matters, and what the jury will see</a:t>
+              <a:t>Trusted deflection that gets smarter every night</a:t>
             </a:r>
             <a:endParaRPr lang="en-US" sz="3000" dirty="0"/>
           </a:p>
@@ -6141,7 +6141,7 @@
                 <a:ea typeface="Calibri" pitchFamily="34" charset="-122"/>
                 <a:cs typeface="Calibri" pitchFamily="34" charset="-120"/>
               </a:rPr>
-              <a:t>Trusted deflection: low-trust answers escalate to the right on-call expert via MCP (with an auto ITSM ticket) instead of reaching the customer.</a:t>
+              <a:t>22% → 94% accuracy and 74% fewer tokens (~4x throughput per GPU).</a:t>
             </a:r>
             <a:endParaRPr lang="en-US" sz="1200" dirty="0"/>
           </a:p>
@@ -6170,7 +6170,7 @@
                 <a:ea typeface="Calibri" pitchFamily="34" charset="-122"/>
                 <a:cs typeface="Calibri" pitchFamily="34" charset="-120"/>
               </a:rPr>
-              <a:t>74% fewer tokens ≈ 4x throughput per GPU. Repeat questions become zero-GPU cache hits. The model improves nightly from human feedback in ~60s of GPU time — no ML team in the loop.</a:t>
+              <a:t>Low-trust answers escalate to the right on-call expert via MCP with an auto ITSM ticket — never reaching the customer. Repeat questions become zero-GPU cache hits, and the model improves nightly from human feedback in ~60s of GPU time, with no ML team in the loop.</a:t>
             </a:r>
             <a:endParaRPr lang="en-US" sz="1200" dirty="0"/>
           </a:p>
@@ -6404,7 +6404,7 @@
                 <a:ea typeface="Calibri" pitchFamily="34" charset="-122"/>
                 <a:cs typeface="Calibri" pitchFamily="34" charset="-120"/>
               </a:rPr>
-              <a:t>DEMO FLOW  (what the jury should notice)</a:t>
+              <a:t>DEMO FLOW — LIVE HIGHLIGHTS</a:t>
             </a:r>
             <a:endParaRPr lang="en-US" sz="1200" dirty="0"/>
           </a:p>

</xml_diff>